<commit_message>
Update diagnostics and outputs for Grandchild ASSIGN model
- Revised `GRANDCHILD_D_and_H_sort_interpretation.md` to clarify the interpretation of D, global_wss, and H_sort metrics, enhancing understanding of model performance.
- Updated metadata files to reflect the latest date and added new empirical data files related to roster caps and league intervals for the years 2011-2021.
- Introduced new visualizations and PNG files to support the analysis of empirical roster caps and selection dynamics.
- Enhanced `statistics.json` to include updated user message counts and last updated timestamps, ensuring accurate tracking of project activity.

These changes improve the documentation and analytical capabilities of the Grandchild ASSIGN model, facilitating better insights into player performance and selection dynamics.
</commit_message>
<xml_diff>
--- a/3-Master_Plan/re_entry/HEROs_and_PASSes/slides/auto/CHAR_empirical_team_interval_overlap_2015_2019_AUTO.pptx
+++ b/3-Master_Plan/re_entry/HEROs_and_PASSes/slides/auto/CHAR_empirical_team_interval_overlap_2015_2019_AUTO.pptx
@@ -5,9 +5,9 @@
     <p:sldMasterId id="2147483648" r:id="rId1"/>
   </p:sldMasterIdLst>
   <p:sldIdLst>
-    <p:sldId id="256" r:id="rId2"/>
+    <p:sldId id="256" r:id="rId7"/>
   </p:sldIdLst>
-  <p:sldSz cx="12192000" cy="6858000"/>
+  <p:sldSz cx="12191695" cy="6858000" type="screen4x3"/>
   <p:notesSz cx="6858000" cy="9144000"/>
   <p:defaultTextStyle>
     <a:defPPr>
@@ -104,22 +104,6 @@
       </a:defRPr>
     </a:lvl9pPr>
   </p:defaultTextStyle>
-  <p:extLst>
-    <p:ext uri="{EFAFB233-063F-42B5-8137-9DF3F51BA10A}">
-      <p15:sldGuideLst xmlns:p15="http://schemas.microsoft.com/office/powerpoint/2012/main">
-        <p15:guide id="1" orient="horz" pos="2160">
-          <p15:clr>
-            <a:srgbClr val="A4A3A4"/>
-          </p15:clr>
-        </p15:guide>
-        <p15:guide id="2" pos="2880">
-          <p15:clr>
-            <a:srgbClr val="A4A3A4"/>
-          </p15:clr>
-        </p15:guide>
-      </p15:sldGuideLst>
-    </p:ext>
-  </p:extLst>
 </p:presentation>
 </file>
 
@@ -161,9 +145,10 @@
           <a:lstStyle/>
           <a:p>
             <a:r>
-              <a:rPr lang="en-US"/>
+              <a:rPr lang="en-US" smtClean="0"/>
               <a:t>Click to edit Master title style</a:t>
             </a:r>
+            <a:endParaRPr lang="en-US"/>
           </a:p>
         </p:txBody>
       </p:sp>
@@ -279,9 +264,10 @@
           </a:lstStyle>
           <a:p>
             <a:r>
-              <a:rPr lang="en-US"/>
+              <a:rPr lang="en-US" smtClean="0"/>
               <a:t>Click to edit Master subtitle style</a:t>
             </a:r>
+            <a:endParaRPr lang="en-US"/>
           </a:p>
         </p:txBody>
       </p:sp>
@@ -302,7 +288,7 @@
           <a:p>
             <a:fld id="{5BCAD085-E8A6-8845-BD4E-CB4CCA059FC4}" type="datetimeFigureOut">
               <a:rPr lang="en-US" smtClean="0"/>
-              <a:t>8/11/26</a:t>
+              <a:t>1/27/13</a:t>
             </a:fld>
             <a:endParaRPr lang="en-US"/>
           </a:p>
@@ -396,9 +382,10 @@
           <a:lstStyle/>
           <a:p>
             <a:r>
-              <a:rPr lang="en-US"/>
+              <a:rPr lang="en-US" smtClean="0"/>
               <a:t>Click to edit Master title style</a:t>
             </a:r>
+            <a:endParaRPr lang="en-US"/>
           </a:p>
         </p:txBody>
       </p:sp>
@@ -419,37 +406,38 @@
           <a:p>
             <a:pPr lvl="0"/>
             <a:r>
-              <a:rPr lang="en-US"/>
+              <a:rPr lang="en-US" smtClean="0"/>
               <a:t>Click to edit Master text styles</a:t>
             </a:r>
           </a:p>
           <a:p>
             <a:pPr lvl="1"/>
             <a:r>
-              <a:rPr lang="en-US"/>
+              <a:rPr lang="en-US" smtClean="0"/>
               <a:t>Second level</a:t>
             </a:r>
           </a:p>
           <a:p>
             <a:pPr lvl="2"/>
             <a:r>
-              <a:rPr lang="en-US"/>
+              <a:rPr lang="en-US" smtClean="0"/>
               <a:t>Third level</a:t>
             </a:r>
           </a:p>
           <a:p>
             <a:pPr lvl="3"/>
             <a:r>
-              <a:rPr lang="en-US"/>
+              <a:rPr lang="en-US" smtClean="0"/>
               <a:t>Fourth level</a:t>
             </a:r>
           </a:p>
           <a:p>
             <a:pPr lvl="4"/>
             <a:r>
-              <a:rPr lang="en-US"/>
+              <a:rPr lang="en-US" smtClean="0"/>
               <a:t>Fifth level</a:t>
             </a:r>
+            <a:endParaRPr lang="en-US"/>
           </a:p>
         </p:txBody>
       </p:sp>
@@ -470,7 +458,7 @@
           <a:p>
             <a:fld id="{5BCAD085-E8A6-8845-BD4E-CB4CCA059FC4}" type="datetimeFigureOut">
               <a:rPr lang="en-US" smtClean="0"/>
-              <a:t>8/11/26</a:t>
+              <a:t>1/27/13</a:t>
             </a:fld>
             <a:endParaRPr lang="en-US"/>
           </a:p>
@@ -569,9 +557,10 @@
           <a:lstStyle/>
           <a:p>
             <a:r>
-              <a:rPr lang="en-US"/>
+              <a:rPr lang="en-US" smtClean="0"/>
               <a:t>Click to edit Master title style</a:t>
             </a:r>
+            <a:endParaRPr lang="en-US"/>
           </a:p>
         </p:txBody>
       </p:sp>
@@ -597,37 +586,38 @@
           <a:p>
             <a:pPr lvl="0"/>
             <a:r>
-              <a:rPr lang="en-US"/>
+              <a:rPr lang="en-US" smtClean="0"/>
               <a:t>Click to edit Master text styles</a:t>
             </a:r>
           </a:p>
           <a:p>
             <a:pPr lvl="1"/>
             <a:r>
-              <a:rPr lang="en-US"/>
+              <a:rPr lang="en-US" smtClean="0"/>
               <a:t>Second level</a:t>
             </a:r>
           </a:p>
           <a:p>
             <a:pPr lvl="2"/>
             <a:r>
-              <a:rPr lang="en-US"/>
+              <a:rPr lang="en-US" smtClean="0"/>
               <a:t>Third level</a:t>
             </a:r>
           </a:p>
           <a:p>
             <a:pPr lvl="3"/>
             <a:r>
-              <a:rPr lang="en-US"/>
+              <a:rPr lang="en-US" smtClean="0"/>
               <a:t>Fourth level</a:t>
             </a:r>
           </a:p>
           <a:p>
             <a:pPr lvl="4"/>
             <a:r>
-              <a:rPr lang="en-US"/>
+              <a:rPr lang="en-US" smtClean="0"/>
               <a:t>Fifth level</a:t>
             </a:r>
+            <a:endParaRPr lang="en-US"/>
           </a:p>
         </p:txBody>
       </p:sp>
@@ -648,7 +638,7 @@
           <a:p>
             <a:fld id="{5BCAD085-E8A6-8845-BD4E-CB4CCA059FC4}" type="datetimeFigureOut">
               <a:rPr lang="en-US" smtClean="0"/>
-              <a:t>8/11/26</a:t>
+              <a:t>1/27/13</a:t>
             </a:fld>
             <a:endParaRPr lang="en-US"/>
           </a:p>
@@ -742,9 +732,10 @@
           <a:lstStyle/>
           <a:p>
             <a:r>
-              <a:rPr lang="en-US"/>
+              <a:rPr lang="en-US" smtClean="0"/>
               <a:t>Click to edit Master title style</a:t>
             </a:r>
+            <a:endParaRPr lang="en-US"/>
           </a:p>
         </p:txBody>
       </p:sp>
@@ -765,37 +756,38 @@
           <a:p>
             <a:pPr lvl="0"/>
             <a:r>
-              <a:rPr lang="en-US"/>
+              <a:rPr lang="en-US" smtClean="0"/>
               <a:t>Click to edit Master text styles</a:t>
             </a:r>
           </a:p>
           <a:p>
             <a:pPr lvl="1"/>
             <a:r>
-              <a:rPr lang="en-US"/>
+              <a:rPr lang="en-US" smtClean="0"/>
               <a:t>Second level</a:t>
             </a:r>
           </a:p>
           <a:p>
             <a:pPr lvl="2"/>
             <a:r>
-              <a:rPr lang="en-US"/>
+              <a:rPr lang="en-US" smtClean="0"/>
               <a:t>Third level</a:t>
             </a:r>
           </a:p>
           <a:p>
             <a:pPr lvl="3"/>
             <a:r>
-              <a:rPr lang="en-US"/>
+              <a:rPr lang="en-US" smtClean="0"/>
               <a:t>Fourth level</a:t>
             </a:r>
           </a:p>
           <a:p>
             <a:pPr lvl="4"/>
             <a:r>
-              <a:rPr lang="en-US"/>
+              <a:rPr lang="en-US" smtClean="0"/>
               <a:t>Fifth level</a:t>
             </a:r>
+            <a:endParaRPr lang="en-US"/>
           </a:p>
         </p:txBody>
       </p:sp>
@@ -816,7 +808,7 @@
           <a:p>
             <a:fld id="{5BCAD085-E8A6-8845-BD4E-CB4CCA059FC4}" type="datetimeFigureOut">
               <a:rPr lang="en-US" smtClean="0"/>
-              <a:t>8/11/26</a:t>
+              <a:t>1/27/13</a:t>
             </a:fld>
             <a:endParaRPr lang="en-US"/>
           </a:p>
@@ -919,9 +911,10 @@
           </a:lstStyle>
           <a:p>
             <a:r>
-              <a:rPr lang="en-US"/>
+              <a:rPr lang="en-US" smtClean="0"/>
               <a:t>Click to edit Master title style</a:t>
             </a:r>
+            <a:endParaRPr lang="en-US"/>
           </a:p>
         </p:txBody>
       </p:sp>
@@ -1038,7 +1031,7 @@
           <a:p>
             <a:pPr lvl="0"/>
             <a:r>
-              <a:rPr lang="en-US"/>
+              <a:rPr lang="en-US" smtClean="0"/>
               <a:t>Click to edit Master text styles</a:t>
             </a:r>
           </a:p>
@@ -1061,7 +1054,7 @@
           <a:p>
             <a:fld id="{5BCAD085-E8A6-8845-BD4E-CB4CCA059FC4}" type="datetimeFigureOut">
               <a:rPr lang="en-US" smtClean="0"/>
-              <a:t>8/11/26</a:t>
+              <a:t>1/27/13</a:t>
             </a:fld>
             <a:endParaRPr lang="en-US"/>
           </a:p>
@@ -1155,9 +1148,10 @@
           <a:lstStyle/>
           <a:p>
             <a:r>
-              <a:rPr lang="en-US"/>
+              <a:rPr lang="en-US" smtClean="0"/>
               <a:t>Click to edit Master title style</a:t>
             </a:r>
+            <a:endParaRPr lang="en-US"/>
           </a:p>
         </p:txBody>
       </p:sp>
@@ -1211,37 +1205,38 @@
           <a:p>
             <a:pPr lvl="0"/>
             <a:r>
-              <a:rPr lang="en-US"/>
+              <a:rPr lang="en-US" smtClean="0"/>
               <a:t>Click to edit Master text styles</a:t>
             </a:r>
           </a:p>
           <a:p>
             <a:pPr lvl="1"/>
             <a:r>
-              <a:rPr lang="en-US"/>
+              <a:rPr lang="en-US" smtClean="0"/>
               <a:t>Second level</a:t>
             </a:r>
           </a:p>
           <a:p>
             <a:pPr lvl="2"/>
             <a:r>
-              <a:rPr lang="en-US"/>
+              <a:rPr lang="en-US" smtClean="0"/>
               <a:t>Third level</a:t>
             </a:r>
           </a:p>
           <a:p>
             <a:pPr lvl="3"/>
             <a:r>
-              <a:rPr lang="en-US"/>
+              <a:rPr lang="en-US" smtClean="0"/>
               <a:t>Fourth level</a:t>
             </a:r>
           </a:p>
           <a:p>
             <a:pPr lvl="4"/>
             <a:r>
-              <a:rPr lang="en-US"/>
+              <a:rPr lang="en-US" smtClean="0"/>
               <a:t>Fifth level</a:t>
             </a:r>
+            <a:endParaRPr lang="en-US"/>
           </a:p>
         </p:txBody>
       </p:sp>
@@ -1295,37 +1290,38 @@
           <a:p>
             <a:pPr lvl="0"/>
             <a:r>
-              <a:rPr lang="en-US"/>
+              <a:rPr lang="en-US" smtClean="0"/>
               <a:t>Click to edit Master text styles</a:t>
             </a:r>
           </a:p>
           <a:p>
             <a:pPr lvl="1"/>
             <a:r>
-              <a:rPr lang="en-US"/>
+              <a:rPr lang="en-US" smtClean="0"/>
               <a:t>Second level</a:t>
             </a:r>
           </a:p>
           <a:p>
             <a:pPr lvl="2"/>
             <a:r>
-              <a:rPr lang="en-US"/>
+              <a:rPr lang="en-US" smtClean="0"/>
               <a:t>Third level</a:t>
             </a:r>
           </a:p>
           <a:p>
             <a:pPr lvl="3"/>
             <a:r>
-              <a:rPr lang="en-US"/>
+              <a:rPr lang="en-US" smtClean="0"/>
               <a:t>Fourth level</a:t>
             </a:r>
           </a:p>
           <a:p>
             <a:pPr lvl="4"/>
             <a:r>
-              <a:rPr lang="en-US"/>
+              <a:rPr lang="en-US" smtClean="0"/>
               <a:t>Fifth level</a:t>
             </a:r>
+            <a:endParaRPr lang="en-US"/>
           </a:p>
         </p:txBody>
       </p:sp>
@@ -1346,7 +1342,7 @@
           <a:p>
             <a:fld id="{5BCAD085-E8A6-8845-BD4E-CB4CCA059FC4}" type="datetimeFigureOut">
               <a:rPr lang="en-US" smtClean="0"/>
-              <a:t>8/11/26</a:t>
+              <a:t>1/27/13</a:t>
             </a:fld>
             <a:endParaRPr lang="en-US"/>
           </a:p>
@@ -1444,9 +1440,10 @@
           </a:lstStyle>
           <a:p>
             <a:r>
-              <a:rPr lang="en-US"/>
+              <a:rPr lang="en-US" smtClean="0"/>
               <a:t>Click to edit Master title style</a:t>
             </a:r>
+            <a:endParaRPr lang="en-US"/>
           </a:p>
         </p:txBody>
       </p:sp>
@@ -1509,7 +1506,7 @@
           <a:p>
             <a:pPr lvl="0"/>
             <a:r>
-              <a:rPr lang="en-US"/>
+              <a:rPr lang="en-US" smtClean="0"/>
               <a:t>Click to edit Master text styles</a:t>
             </a:r>
           </a:p>
@@ -1565,37 +1562,38 @@
           <a:p>
             <a:pPr lvl="0"/>
             <a:r>
-              <a:rPr lang="en-US"/>
+              <a:rPr lang="en-US" smtClean="0"/>
               <a:t>Click to edit Master text styles</a:t>
             </a:r>
           </a:p>
           <a:p>
             <a:pPr lvl="1"/>
             <a:r>
-              <a:rPr lang="en-US"/>
+              <a:rPr lang="en-US" smtClean="0"/>
               <a:t>Second level</a:t>
             </a:r>
           </a:p>
           <a:p>
             <a:pPr lvl="2"/>
             <a:r>
-              <a:rPr lang="en-US"/>
+              <a:rPr lang="en-US" smtClean="0"/>
               <a:t>Third level</a:t>
             </a:r>
           </a:p>
           <a:p>
             <a:pPr lvl="3"/>
             <a:r>
-              <a:rPr lang="en-US"/>
+              <a:rPr lang="en-US" smtClean="0"/>
               <a:t>Fourth level</a:t>
             </a:r>
           </a:p>
           <a:p>
             <a:pPr lvl="4"/>
             <a:r>
-              <a:rPr lang="en-US"/>
+              <a:rPr lang="en-US" smtClean="0"/>
               <a:t>Fifth level</a:t>
             </a:r>
+            <a:endParaRPr lang="en-US"/>
           </a:p>
         </p:txBody>
       </p:sp>
@@ -1658,7 +1656,7 @@
           <a:p>
             <a:pPr lvl="0"/>
             <a:r>
-              <a:rPr lang="en-US"/>
+              <a:rPr lang="en-US" smtClean="0"/>
               <a:t>Click to edit Master text styles</a:t>
             </a:r>
           </a:p>
@@ -1714,37 +1712,38 @@
           <a:p>
             <a:pPr lvl="0"/>
             <a:r>
-              <a:rPr lang="en-US"/>
+              <a:rPr lang="en-US" smtClean="0"/>
               <a:t>Click to edit Master text styles</a:t>
             </a:r>
           </a:p>
           <a:p>
             <a:pPr lvl="1"/>
             <a:r>
-              <a:rPr lang="en-US"/>
+              <a:rPr lang="en-US" smtClean="0"/>
               <a:t>Second level</a:t>
             </a:r>
           </a:p>
           <a:p>
             <a:pPr lvl="2"/>
             <a:r>
-              <a:rPr lang="en-US"/>
+              <a:rPr lang="en-US" smtClean="0"/>
               <a:t>Third level</a:t>
             </a:r>
           </a:p>
           <a:p>
             <a:pPr lvl="3"/>
             <a:r>
-              <a:rPr lang="en-US"/>
+              <a:rPr lang="en-US" smtClean="0"/>
               <a:t>Fourth level</a:t>
             </a:r>
           </a:p>
           <a:p>
             <a:pPr lvl="4"/>
             <a:r>
-              <a:rPr lang="en-US"/>
+              <a:rPr lang="en-US" smtClean="0"/>
               <a:t>Fifth level</a:t>
             </a:r>
+            <a:endParaRPr lang="en-US"/>
           </a:p>
         </p:txBody>
       </p:sp>
@@ -1765,7 +1764,7 @@
           <a:p>
             <a:fld id="{5BCAD085-E8A6-8845-BD4E-CB4CCA059FC4}" type="datetimeFigureOut">
               <a:rPr lang="en-US" smtClean="0"/>
-              <a:t>8/11/26</a:t>
+              <a:t>1/27/13</a:t>
             </a:fld>
             <a:endParaRPr lang="en-US"/>
           </a:p>
@@ -1859,9 +1858,10 @@
           <a:lstStyle/>
           <a:p>
             <a:r>
-              <a:rPr lang="en-US"/>
+              <a:rPr lang="en-US" smtClean="0"/>
               <a:t>Click to edit Master title style</a:t>
             </a:r>
+            <a:endParaRPr lang="en-US"/>
           </a:p>
         </p:txBody>
       </p:sp>
@@ -1882,7 +1882,7 @@
           <a:p>
             <a:fld id="{5BCAD085-E8A6-8845-BD4E-CB4CCA059FC4}" type="datetimeFigureOut">
               <a:rPr lang="en-US" smtClean="0"/>
-              <a:t>8/11/26</a:t>
+              <a:t>1/27/13</a:t>
             </a:fld>
             <a:endParaRPr lang="en-US"/>
           </a:p>
@@ -1977,7 +1977,7 @@
           <a:p>
             <a:fld id="{5BCAD085-E8A6-8845-BD4E-CB4CCA059FC4}" type="datetimeFigureOut">
               <a:rPr lang="en-US" smtClean="0"/>
-              <a:t>8/11/26</a:t>
+              <a:t>1/27/13</a:t>
             </a:fld>
             <a:endParaRPr lang="en-US"/>
           </a:p>
@@ -2080,9 +2080,10 @@
           </a:lstStyle>
           <a:p>
             <a:r>
-              <a:rPr lang="en-US"/>
+              <a:rPr lang="en-US" smtClean="0"/>
               <a:t>Click to edit Master title style</a:t>
             </a:r>
+            <a:endParaRPr lang="en-US"/>
           </a:p>
         </p:txBody>
       </p:sp>
@@ -2136,37 +2137,38 @@
           <a:p>
             <a:pPr lvl="0"/>
             <a:r>
-              <a:rPr lang="en-US"/>
+              <a:rPr lang="en-US" smtClean="0"/>
               <a:t>Click to edit Master text styles</a:t>
             </a:r>
           </a:p>
           <a:p>
             <a:pPr lvl="1"/>
             <a:r>
-              <a:rPr lang="en-US"/>
+              <a:rPr lang="en-US" smtClean="0"/>
               <a:t>Second level</a:t>
             </a:r>
           </a:p>
           <a:p>
             <a:pPr lvl="2"/>
             <a:r>
-              <a:rPr lang="en-US"/>
+              <a:rPr lang="en-US" smtClean="0"/>
               <a:t>Third level</a:t>
             </a:r>
           </a:p>
           <a:p>
             <a:pPr lvl="3"/>
             <a:r>
-              <a:rPr lang="en-US"/>
+              <a:rPr lang="en-US" smtClean="0"/>
               <a:t>Fourth level</a:t>
             </a:r>
           </a:p>
           <a:p>
             <a:pPr lvl="4"/>
             <a:r>
-              <a:rPr lang="en-US"/>
+              <a:rPr lang="en-US" smtClean="0"/>
               <a:t>Fifth level</a:t>
             </a:r>
+            <a:endParaRPr lang="en-US"/>
           </a:p>
         </p:txBody>
       </p:sp>
@@ -2229,7 +2231,7 @@
           <a:p>
             <a:pPr lvl="0"/>
             <a:r>
-              <a:rPr lang="en-US"/>
+              <a:rPr lang="en-US" smtClean="0"/>
               <a:t>Click to edit Master text styles</a:t>
             </a:r>
           </a:p>
@@ -2252,7 +2254,7 @@
           <a:p>
             <a:fld id="{5BCAD085-E8A6-8845-BD4E-CB4CCA059FC4}" type="datetimeFigureOut">
               <a:rPr lang="en-US" smtClean="0"/>
-              <a:t>8/11/26</a:t>
+              <a:t>1/27/13</a:t>
             </a:fld>
             <a:endParaRPr lang="en-US"/>
           </a:p>
@@ -2355,9 +2357,10 @@
           </a:lstStyle>
           <a:p>
             <a:r>
-              <a:rPr lang="en-US"/>
+              <a:rPr lang="en-US" smtClean="0"/>
               <a:t>Click to edit Master title style</a:t>
             </a:r>
+            <a:endParaRPr lang="en-US"/>
           </a:p>
         </p:txBody>
       </p:sp>
@@ -2481,7 +2484,7 @@
           <a:p>
             <a:pPr lvl="0"/>
             <a:r>
-              <a:rPr lang="en-US"/>
+              <a:rPr lang="en-US" smtClean="0"/>
               <a:t>Click to edit Master text styles</a:t>
             </a:r>
           </a:p>
@@ -2504,7 +2507,7 @@
           <a:p>
             <a:fld id="{5BCAD085-E8A6-8845-BD4E-CB4CCA059FC4}" type="datetimeFigureOut">
               <a:rPr lang="en-US" smtClean="0"/>
-              <a:t>8/11/26</a:t>
+              <a:t>1/27/13</a:t>
             </a:fld>
             <a:endParaRPr lang="en-US"/>
           </a:p>
@@ -2613,9 +2616,10 @@
           <a:lstStyle/>
           <a:p>
             <a:r>
-              <a:rPr lang="en-US"/>
+              <a:rPr lang="en-US" smtClean="0"/>
               <a:t>Click to edit Master title style</a:t>
             </a:r>
+            <a:endParaRPr lang="en-US"/>
           </a:p>
         </p:txBody>
       </p:sp>
@@ -2646,37 +2650,38 @@
           <a:p>
             <a:pPr lvl="0"/>
             <a:r>
-              <a:rPr lang="en-US"/>
+              <a:rPr lang="en-US" smtClean="0"/>
               <a:t>Click to edit Master text styles</a:t>
             </a:r>
           </a:p>
           <a:p>
             <a:pPr lvl="1"/>
             <a:r>
-              <a:rPr lang="en-US"/>
+              <a:rPr lang="en-US" smtClean="0"/>
               <a:t>Second level</a:t>
             </a:r>
           </a:p>
           <a:p>
             <a:pPr lvl="2"/>
             <a:r>
-              <a:rPr lang="en-US"/>
+              <a:rPr lang="en-US" smtClean="0"/>
               <a:t>Third level</a:t>
             </a:r>
           </a:p>
           <a:p>
             <a:pPr lvl="3"/>
             <a:r>
-              <a:rPr lang="en-US"/>
+              <a:rPr lang="en-US" smtClean="0"/>
               <a:t>Fourth level</a:t>
             </a:r>
           </a:p>
           <a:p>
             <a:pPr lvl="4"/>
             <a:r>
-              <a:rPr lang="en-US"/>
+              <a:rPr lang="en-US" smtClean="0"/>
               <a:t>Fifth level</a:t>
             </a:r>
+            <a:endParaRPr lang="en-US"/>
           </a:p>
         </p:txBody>
       </p:sp>
@@ -2715,7 +2720,7 @@
           <a:p>
             <a:fld id="{5BCAD085-E8A6-8845-BD4E-CB4CCA059FC4}" type="datetimeFigureOut">
               <a:rPr lang="en-US" smtClean="0"/>
-              <a:t>8/11/26</a:t>
+              <a:t>1/27/13</a:t>
             </a:fld>
             <a:endParaRPr lang="en-US"/>
           </a:p>
@@ -3074,7 +3079,7 @@
 </file>
 
 <file path=ppt/slides/slide1.xml><?xml version="1.0" encoding="utf-8"?>
-<p:sld xmlns:a="http://schemas.openxmlformats.org/drawingml/2006/main" xmlns:r="http://schemas.openxmlformats.org/officeDocument/2006/relationships" xmlns:p="http://schemas.openxmlformats.org/presentationml/2006/main">
+<p:sld xmlns:a="http://schemas.openxmlformats.org/drawingml/2006/main" xmlns:p="http://schemas.openxmlformats.org/presentationml/2006/main" xmlns:r="http://schemas.openxmlformats.org/officeDocument/2006/relationships">
   <p:cSld>
     <p:spTree>
       <p:nvGrpSpPr>
@@ -3082,269 +3087,69 @@
         <p:cNvGrpSpPr/>
         <p:nvPr/>
       </p:nvGrpSpPr>
-      <p:grpSpPr>
-        <a:xfrm>
-          <a:off x="0" y="0"/>
-          <a:ext cx="0" cy="0"/>
-          <a:chOff x="0" y="0"/>
-          <a:chExt cx="0" cy="0"/>
-        </a:xfrm>
-      </p:grpSpPr>
-      <mc:AlternateContent xmlns:mc="http://schemas.openxmlformats.org/markup-compatibility/2006">
-        <mc:Choice xmlns:a14="http://schemas.microsoft.com/office/drawing/2010/main" Requires="a14">
-          <p:sp>
-            <p:nvSpPr>
-              <p:cNvPr id="2" name="TextBox 1"/>
-              <p:cNvSpPr txBox="1"/>
-              <p:nvPr/>
-            </p:nvSpPr>
-            <p:spPr>
-              <a:xfrm>
-                <a:off x="384048" y="219456"/>
-                <a:ext cx="5685082" cy="418191"/>
-              </a:xfrm>
-              <a:prstGeom prst="rect">
-                <a:avLst/>
-              </a:prstGeom>
-              <a:noFill/>
-            </p:spPr>
-            <p:txBody>
-              <a:bodyPr wrap="none">
-                <a:spAutoFit/>
-              </a:bodyPr>
-              <a:lstStyle/>
-              <a:p>
-                <a:r>
-                  <a:rPr sz="2000" b="1" i="0" baseline="0" dirty="0">
-                    <a:latin typeface="Calibri"/>
-                  </a:rPr>
-                  <a:t>PD17 — NCAA team </a:t>
-                </a:r>
-                <a14:m>
-                  <m:oMath xmlns:m="http://schemas.openxmlformats.org/officeDocument/2006/math">
-                    <m:sSub>
-                      <m:sSubPr>
-                        <m:ctrlPr>
-                          <a:rPr lang="en-US" sz="2000" b="1" i="1" baseline="0" dirty="0" smtClean="0">
-                            <a:latin typeface="Cambria Math" panose="02040503050406030204" pitchFamily="18" charset="0"/>
-                          </a:rPr>
-                        </m:ctrlPr>
-                      </m:sSubPr>
-                      <m:e>
-                        <m:acc>
-                          <m:accPr>
-                            <m:chr m:val="ˆ"/>
-                            <m:ctrlPr>
-                              <a:rPr lang="en-US" sz="2000" b="1" i="1" baseline="0" dirty="0" smtClean="0">
-                                <a:latin typeface="Cambria Math" panose="02040503050406030204" pitchFamily="18" charset="0"/>
-                              </a:rPr>
-                            </m:ctrlPr>
-                          </m:accPr>
-                          <m:e>
-                            <m:r>
-                              <a:rPr lang="en-US" sz="2000" b="1" i="1" baseline="0" dirty="0" smtClean="0">
-                                <a:latin typeface="Cambria Math" panose="02040503050406030204" pitchFamily="18" charset="0"/>
-                              </a:rPr>
-                              <m:t>𝐴</m:t>
-                            </m:r>
-                          </m:e>
-                        </m:acc>
-                      </m:e>
-                      <m:sub>
-                        <m:r>
-                          <a:rPr lang="en-US" sz="2000" b="1" i="1" baseline="0" dirty="0" smtClean="0">
-                            <a:latin typeface="Cambria Math" panose="02040503050406030204" pitchFamily="18" charset="0"/>
-                          </a:rPr>
-                          <m:t>𝑖</m:t>
-                        </m:r>
-                      </m:sub>
-                    </m:sSub>
-                  </m:oMath>
-                </a14:m>
-                <a:r>
-                  <a:rPr sz="2000" b="1" i="0" baseline="0" dirty="0">
-                    <a:latin typeface="Calibri"/>
-                  </a:rPr>
-                  <a:t> interval overlap (2015-2019)</a:t>
-                </a:r>
-              </a:p>
-            </p:txBody>
-          </p:sp>
-        </mc:Choice>
-        <mc:Fallback>
-          <p:sp>
-            <p:nvSpPr>
-              <p:cNvPr id="2" name="TextBox 1"/>
-              <p:cNvSpPr txBox="1">
-                <a:spLocks noRot="1" noChangeAspect="1" noMove="1" noResize="1" noEditPoints="1" noAdjustHandles="1" noChangeArrowheads="1" noChangeShapeType="1" noTextEdit="1"/>
-              </p:cNvSpPr>
-              <p:nvPr/>
-            </p:nvSpPr>
-            <p:spPr>
-              <a:xfrm>
-                <a:off x="384048" y="219456"/>
-                <a:ext cx="5685082" cy="418191"/>
-              </a:xfrm>
-              <a:prstGeom prst="rect">
-                <a:avLst/>
-              </a:prstGeom>
-              <a:blipFill>
-                <a:blip r:embed="rId2"/>
-                <a:stretch>
-                  <a:fillRect l="-1114" t="-14706" b="-23529"/>
-                </a:stretch>
-              </a:blipFill>
-            </p:spPr>
-            <p:txBody>
-              <a:bodyPr/>
-              <a:lstStyle/>
-              <a:p>
-                <a:r>
-                  <a:rPr lang="en-US">
-                    <a:noFill/>
-                  </a:rPr>
-                  <a:t> </a:t>
-                </a:r>
-              </a:p>
-            </p:txBody>
-          </p:sp>
-        </mc:Fallback>
-      </mc:AlternateContent>
-      <mc:AlternateContent xmlns:mc="http://schemas.openxmlformats.org/markup-compatibility/2006">
-        <mc:Choice xmlns:a14="http://schemas.microsoft.com/office/drawing/2010/main" Requires="a14">
-          <p:sp>
-            <p:nvSpPr>
-              <p:cNvPr id="3" name="TextBox 2"/>
-              <p:cNvSpPr txBox="1"/>
-              <p:nvPr/>
-            </p:nvSpPr>
-            <p:spPr>
-              <a:xfrm>
-                <a:off x="384048" y="713232"/>
-                <a:ext cx="7075463" cy="246221"/>
-              </a:xfrm>
-              <a:prstGeom prst="rect">
-                <a:avLst/>
-              </a:prstGeom>
-              <a:noFill/>
-            </p:spPr>
-            <p:txBody>
-              <a:bodyPr wrap="none">
-                <a:spAutoFit/>
-              </a:bodyPr>
-              <a:lstStyle/>
-              <a:p>
-                <a:r>
-                  <a:rPr sz="1000" b="0" i="0" baseline="0" dirty="0">
-                    <a:latin typeface="Calibri"/>
-                  </a:rPr>
-                  <a:t>MBB 2015-2019 · PPM z within season · min 20 min · </a:t>
-                </a:r>
-                <a:r>
-                  <a:rPr sz="1000" b="0" i="0" baseline="0" dirty="0" err="1">
-                    <a:latin typeface="Calibri"/>
-                  </a:rPr>
-                  <a:t>poolq</a:t>
-                </a:r>
-                <a:r>
-                  <a:rPr sz="1000" b="0" i="0" baseline="0" dirty="0">
-                    <a:latin typeface="Calibri"/>
-                  </a:rPr>
-                  <a:t> </a:t>
-                </a:r>
-                <a:r>
-                  <a:rPr sz="1000" b="0" i="0" baseline="0" dirty="0" err="1">
-                    <a:latin typeface="Calibri"/>
-                  </a:rPr>
-                  <a:t>winsor</a:t>
-                </a:r>
-                <a:r>
-                  <a:rPr sz="1000" b="0" i="0" baseline="0" dirty="0">
-                    <a:latin typeface="Calibri"/>
-                  </a:rPr>
-                  <a:t> 0.01–0.99 · 3,200 team-seasons (530 CELL 8 port) · </a:t>
-                </a:r>
-                <a14:m>
-                  <m:oMath xmlns:m="http://schemas.openxmlformats.org/officeDocument/2006/math">
-                    <m:sSub>
-                      <m:sSubPr>
-                        <m:ctrlPr>
-                          <a:rPr lang="en-US" sz="1000" b="0" i="0" baseline="0" dirty="0">
-                            <a:latin typeface="Cambria Math" panose="02040503050406030204" pitchFamily="18" charset="0"/>
-                          </a:rPr>
-                        </m:ctrlPr>
-                      </m:sSubPr>
-                      <m:e>
-                        <m:r>
-                          <a:rPr lang="en-US" sz="1000" b="0" i="0" baseline="0" dirty="0">
-                            <a:latin typeface="Cambria Math" panose="02040503050406030204" pitchFamily="18" charset="0"/>
-                          </a:rPr>
-                          <m:t>𝐻</m:t>
-                        </m:r>
-                      </m:e>
-                      <m:sub>
-                        <m:r>
-                          <a:rPr lang="en-US" sz="1000" b="0" i="0" baseline="0" dirty="0">
-                            <a:latin typeface="Cambria Math" panose="02040503050406030204" pitchFamily="18" charset="0"/>
-                          </a:rPr>
-                          <m:t>𝑠𝑜𝑟𝑡</m:t>
-                        </m:r>
-                      </m:sub>
-                    </m:sSub>
-                    <m:r>
-                      <a:rPr lang="en-US" sz="1000" b="0" i="0" baseline="0" dirty="0">
-                        <a:latin typeface="Cambria Math" panose="02040503050406030204" pitchFamily="18" charset="0"/>
-                      </a:rPr>
-                      <m:t>=0.105</m:t>
-                    </m:r>
-                  </m:oMath>
-                </a14:m>
-                <a:endParaRPr sz="1000" b="0" i="0" baseline="0" dirty="0">
-                  <a:latin typeface="Calibri"/>
-                </a:endParaRPr>
-              </a:p>
-            </p:txBody>
-          </p:sp>
-        </mc:Choice>
-        <mc:Fallback>
-          <p:sp>
-            <p:nvSpPr>
-              <p:cNvPr id="3" name="TextBox 2"/>
-              <p:cNvSpPr txBox="1">
-                <a:spLocks noRot="1" noChangeAspect="1" noMove="1" noResize="1" noEditPoints="1" noAdjustHandles="1" noChangeArrowheads="1" noChangeShapeType="1" noTextEdit="1"/>
-              </p:cNvSpPr>
-              <p:nvPr/>
-            </p:nvSpPr>
-            <p:spPr>
-              <a:xfrm>
-                <a:off x="384048" y="713232"/>
-                <a:ext cx="7075463" cy="246221"/>
-              </a:xfrm>
-              <a:prstGeom prst="rect">
-                <a:avLst/>
-              </a:prstGeom>
-              <a:blipFill>
-                <a:blip r:embed="rId3"/>
-                <a:stretch>
-                  <a:fillRect b="-10000"/>
-                </a:stretch>
-              </a:blipFill>
-            </p:spPr>
-            <p:txBody>
-              <a:bodyPr/>
-              <a:lstStyle/>
-              <a:p>
-                <a:r>
-                  <a:rPr lang="en-US">
-                    <a:noFill/>
-                  </a:rPr>
-                  <a:t> </a:t>
-                </a:r>
-              </a:p>
-            </p:txBody>
-          </p:sp>
-        </mc:Fallback>
-      </mc:AlternateContent>
+      <p:grpSpPr/>
+      <p:sp>
+        <p:nvSpPr>
+          <p:cNvPr id="2" name="TextBox 1"/>
+          <p:cNvSpPr txBox="1"/>
+          <p:nvPr/>
+        </p:nvSpPr>
+        <p:spPr>
+          <a:xfrm>
+            <a:off x="384048" y="219456"/>
+            <a:ext cx="11423599" cy="457200"/>
+          </a:xfrm>
+          <a:prstGeom prst="rect">
+            <a:avLst/>
+          </a:prstGeom>
+          <a:noFill/>
+        </p:spPr>
+        <p:txBody>
+          <a:bodyPr wrap="none">
+            <a:spAutoFit/>
+          </a:bodyPr>
+          <a:lstStyle/>
+          <a:p>
+            <a:r>
+              <a:rPr sz="2000" b="1" i="0" baseline="0">
+                <a:latin typeface="Calibri"/>
+              </a:rPr>
+              <a:t>PD17 — NCAA team \hat{A}_{i} interval overlap (2015-2019)</a:t>
+            </a:r>
+          </a:p>
+        </p:txBody>
+      </p:sp>
+      <p:sp>
+        <p:nvSpPr>
+          <p:cNvPr id="3" name="TextBox 2"/>
+          <p:cNvSpPr txBox="1"/>
+          <p:nvPr/>
+        </p:nvSpPr>
+        <p:spPr>
+          <a:xfrm>
+            <a:off x="384048" y="713232"/>
+            <a:ext cx="11423599" cy="246888"/>
+          </a:xfrm>
+          <a:prstGeom prst="rect">
+            <a:avLst/>
+          </a:prstGeom>
+          <a:noFill/>
+        </p:spPr>
+        <p:txBody>
+          <a:bodyPr wrap="none">
+            <a:spAutoFit/>
+          </a:bodyPr>
+          <a:lstStyle/>
+          <a:p>
+            <a:r>
+              <a:rPr sz="1000" b="0" i="0" baseline="0">
+                <a:latin typeface="Calibri"/>
+              </a:rPr>
+              <a:t>MBB 2015-2019 · PPM z within season · min 20 min · poolq winsor 0.01–0.99 · 3,200 team-seasons (530 CELL 8 port) · H_{sort}=0.105</a:t>
+            </a:r>
+          </a:p>
+        </p:txBody>
+      </p:sp>
       <p:pic>
         <p:nvPicPr>
           <p:cNvPr id="4" name="Picture 3" descr="EMPIRICAL_team_interval_overlap_2015_2019.png"/>
@@ -3354,7 +3159,7 @@
           <p:nvPr/>
         </p:nvPicPr>
         <p:blipFill>
-          <a:blip r:embed="rId4"/>
+          <a:blip r:embed="rId2"/>
           <a:stretch>
             <a:fillRect/>
           </a:stretch>
@@ -3369,780 +3174,229 @@
           </a:prstGeom>
         </p:spPr>
       </p:pic>
-      <mc:AlternateContent xmlns:mc="http://schemas.openxmlformats.org/markup-compatibility/2006">
-        <mc:Choice xmlns:a14="http://schemas.microsoft.com/office/drawing/2010/main" Requires="a14">
-          <p:sp>
-            <p:nvSpPr>
-              <p:cNvPr id="5" name="TextBox 4"/>
-              <p:cNvSpPr txBox="1"/>
-              <p:nvPr/>
-            </p:nvSpPr>
-            <p:spPr>
-              <a:xfrm>
-                <a:off x="384047" y="1202289"/>
-                <a:ext cx="4387055" cy="2704074"/>
-              </a:xfrm>
-              <a:prstGeom prst="rect">
-                <a:avLst/>
-              </a:prstGeom>
-              <a:noFill/>
-            </p:spPr>
-            <p:txBody>
-              <a:bodyPr wrap="square">
-                <a:spAutoFit/>
-              </a:bodyPr>
-              <a:lstStyle/>
-              <a:p>
-                <a:pPr>
-                  <a:lnSpc>
-                    <a:spcPct val="150000"/>
-                  </a:lnSpc>
-                  <a:buChar char="•"/>
-                </a:pPr>
-                <a:r>
-                  <a:rPr sz="1000" b="0" i="0" baseline="0" dirty="0">
-                    <a:latin typeface="Calibri"/>
-                  </a:rPr>
-                  <a:t>  Each team-season: talent window [</a:t>
-                </a:r>
-                <a14:m>
-                  <m:oMath xmlns:m="http://schemas.openxmlformats.org/officeDocument/2006/math">
-                    <m:func>
-                      <m:funcPr>
-                        <m:ctrlPr>
-                          <a:rPr lang="en-US" sz="1000" b="0" i="0" baseline="0" dirty="0">
-                            <a:latin typeface="Cambria Math" panose="02040503050406030204" pitchFamily="18" charset="0"/>
-                          </a:rPr>
-                        </m:ctrlPr>
-                      </m:funcPr>
-                      <m:fName>
-                        <m:r>
-                          <m:rPr>
-                            <m:sty m:val="p"/>
-                          </m:rPr>
-                          <a:rPr lang="en-US" sz="1000" b="0" i="0" baseline="0" dirty="0">
-                            <a:latin typeface="Cambria Math" panose="02040503050406030204" pitchFamily="18" charset="0"/>
-                          </a:rPr>
-                          <m:t>min</m:t>
-                        </m:r>
-                      </m:fName>
-                      <m:e>
-                        <m:sSub>
-                          <m:sSubPr>
-                            <m:ctrlPr>
-                              <a:rPr lang="en-US" sz="1000" b="0" i="0" baseline="0" dirty="0">
-                                <a:latin typeface="Cambria Math" panose="02040503050406030204" pitchFamily="18" charset="0"/>
-                              </a:rPr>
-                            </m:ctrlPr>
-                          </m:sSubPr>
-                          <m:e>
-                            <m:acc>
-                              <m:accPr>
-                                <m:chr m:val="ˆ"/>
-                                <m:ctrlPr>
-                                  <a:rPr lang="en-US" sz="1000" b="0" i="0" baseline="0" dirty="0">
-                                    <a:latin typeface="Cambria Math" panose="02040503050406030204" pitchFamily="18" charset="0"/>
-                                  </a:rPr>
-                                </m:ctrlPr>
-                              </m:accPr>
-                              <m:e>
-                                <m:r>
-                                  <a:rPr lang="en-US" sz="1000" b="0" i="0" baseline="0" dirty="0">
-                                    <a:latin typeface="Cambria Math" panose="02040503050406030204" pitchFamily="18" charset="0"/>
-                                  </a:rPr>
-                                  <m:t>𝐴</m:t>
-                                </m:r>
-                              </m:e>
-                            </m:acc>
-                          </m:e>
-                          <m:sub>
-                            <m:r>
-                              <a:rPr lang="en-US" sz="1000" b="0" i="0" baseline="0" dirty="0">
-                                <a:latin typeface="Cambria Math" panose="02040503050406030204" pitchFamily="18" charset="0"/>
-                              </a:rPr>
-                              <m:t>𝑖</m:t>
-                            </m:r>
-                          </m:sub>
-                        </m:sSub>
-                      </m:e>
-                    </m:func>
-                    <m:r>
-                      <a:rPr lang="en-US" sz="1000" b="0" i="0" baseline="0" dirty="0">
-                        <a:latin typeface="Cambria Math" panose="02040503050406030204" pitchFamily="18" charset="0"/>
-                      </a:rPr>
-                      <m:t>,</m:t>
-                    </m:r>
-                    <m:func>
-                      <m:funcPr>
-                        <m:ctrlPr>
-                          <a:rPr lang="en-US" sz="1000" b="0" i="0" baseline="0" dirty="0">
-                            <a:latin typeface="Cambria Math" panose="02040503050406030204" pitchFamily="18" charset="0"/>
-                          </a:rPr>
-                        </m:ctrlPr>
-                      </m:funcPr>
-                      <m:fName>
-                        <m:r>
-                          <m:rPr>
-                            <m:sty m:val="p"/>
-                          </m:rPr>
-                          <a:rPr lang="en-US" sz="1000" b="0" i="0" baseline="0" dirty="0">
-                            <a:latin typeface="Cambria Math" panose="02040503050406030204" pitchFamily="18" charset="0"/>
-                          </a:rPr>
-                          <m:t>max</m:t>
-                        </m:r>
-                      </m:fName>
-                      <m:e>
-                        <m:sSub>
-                          <m:sSubPr>
-                            <m:ctrlPr>
-                              <a:rPr lang="en-US" sz="1000" b="0" i="0" baseline="0" dirty="0">
-                                <a:latin typeface="Cambria Math" panose="02040503050406030204" pitchFamily="18" charset="0"/>
-                              </a:rPr>
-                            </m:ctrlPr>
-                          </m:sSubPr>
-                          <m:e>
-                            <m:acc>
-                              <m:accPr>
-                                <m:chr m:val="ˆ"/>
-                                <m:ctrlPr>
-                                  <a:rPr lang="en-US" sz="1000" b="0" i="0" baseline="0" dirty="0">
-                                    <a:latin typeface="Cambria Math" panose="02040503050406030204" pitchFamily="18" charset="0"/>
-                                  </a:rPr>
-                                </m:ctrlPr>
-                              </m:accPr>
-                              <m:e>
-                                <m:r>
-                                  <a:rPr lang="en-US" sz="1000" b="0" i="0" baseline="0" dirty="0">
-                                    <a:latin typeface="Cambria Math" panose="02040503050406030204" pitchFamily="18" charset="0"/>
-                                  </a:rPr>
-                                  <m:t>𝐴</m:t>
-                                </m:r>
-                              </m:e>
-                            </m:acc>
-                          </m:e>
-                          <m:sub>
-                            <m:r>
-                              <a:rPr lang="en-US" sz="1000" b="0" i="0" baseline="0" dirty="0">
-                                <a:latin typeface="Cambria Math" panose="02040503050406030204" pitchFamily="18" charset="0"/>
-                              </a:rPr>
-                              <m:t>𝑖</m:t>
-                            </m:r>
-                          </m:sub>
-                        </m:sSub>
-                      </m:e>
-                    </m:func>
-                  </m:oMath>
-                </a14:m>
-                <a:r>
-                  <a:rPr sz="1000" b="0" i="0" baseline="0" dirty="0">
-                    <a:latin typeface="Calibri"/>
-                  </a:rPr>
-                  <a:t>] on PPM z.</a:t>
-                </a:r>
-              </a:p>
-              <a:p>
-                <a:pPr>
-                  <a:lnSpc>
-                    <a:spcPct val="150000"/>
-                  </a:lnSpc>
-                  <a:buChar char="•"/>
-                </a:pPr>
-                <a:r>
-                  <a:rPr sz="1000" b="0" i="0" baseline="0" dirty="0">
-                    <a:latin typeface="Calibri"/>
-                  </a:rPr>
-                  <a:t>  Coverage = how many windows cover a point on the spectrum (530 CELL 8).</a:t>
-                </a:r>
-              </a:p>
-              <a:p>
-                <a:pPr>
-                  <a:lnSpc>
-                    <a:spcPct val="150000"/>
-                  </a:lnSpc>
-                  <a:buChar char="•"/>
-                </a:pPr>
-                <a:r>
-                  <a:rPr sz="1000" b="0" i="0" baseline="0" dirty="0">
-                    <a:latin typeface="Calibri"/>
-                  </a:rPr>
-                  <a:t>  Red dashed: disjoint sort-and-chop on same player-seasons (537 B analog).</a:t>
-                </a:r>
-              </a:p>
-              <a:p>
-                <a:pPr>
-                  <a:lnSpc>
-                    <a:spcPct val="150000"/>
-                  </a:lnSpc>
-                  <a:buChar char="•"/>
-                </a:pPr>
-                <a:r>
-                  <a:rPr sz="1000" b="0" i="0" baseline="0" dirty="0">
-                    <a:latin typeface="Calibri"/>
-                  </a:rPr>
-                  <a:t>  </a:t>
-                </a:r>
-                <a14:m>
-                  <m:oMath xmlns:m="http://schemas.openxmlformats.org/officeDocument/2006/math">
-                    <m:sSub>
-                      <m:sSubPr>
-                        <m:ctrlPr>
-                          <a:rPr lang="en-US" sz="1000" b="0" i="0" baseline="0" dirty="0">
-                            <a:latin typeface="Cambria Math" panose="02040503050406030204" pitchFamily="18" charset="0"/>
-                          </a:rPr>
-                        </m:ctrlPr>
-                      </m:sSubPr>
-                      <m:e>
-                        <m:r>
-                          <a:rPr lang="en-US" sz="1000" b="0" i="0" baseline="0" dirty="0">
-                            <a:latin typeface="Cambria Math" panose="02040503050406030204" pitchFamily="18" charset="0"/>
-                          </a:rPr>
-                          <m:t>𝐻</m:t>
-                        </m:r>
-                      </m:e>
-                      <m:sub>
-                        <m:r>
-                          <a:rPr lang="en-US" sz="1000" b="0" i="0" baseline="0" dirty="0">
-                            <a:latin typeface="Cambria Math" panose="02040503050406030204" pitchFamily="18" charset="0"/>
-                          </a:rPr>
-                          <m:t>𝑠𝑜𝑟𝑡</m:t>
-                        </m:r>
-                      </m:sub>
-                    </m:sSub>
-                    <m:r>
-                      <a:rPr lang="en-US" sz="1000" b="0" i="0" baseline="0" dirty="0">
-                        <a:latin typeface="Cambria Math" panose="02040503050406030204" pitchFamily="18" charset="0"/>
-                      </a:rPr>
-                      <m:t>=1−</m:t>
-                    </m:r>
-                    <m:nary>
-                      <m:naryPr>
-                        <m:chr m:val="∑"/>
-                        <m:limLoc m:val="undOvr"/>
-                        <m:supHide m:val="on"/>
-                        <m:ctrlPr>
-                          <a:rPr lang="en-US" sz="1000" b="0" i="0" baseline="0" dirty="0">
-                            <a:latin typeface="Cambria Math" panose="02040503050406030204" pitchFamily="18" charset="0"/>
-                          </a:rPr>
-                        </m:ctrlPr>
-                      </m:naryPr>
-                      <m:sub>
-                        <m:r>
-                          <a:rPr lang="en-US" sz="1000" b="0" i="0" baseline="0" dirty="0">
-                            <a:latin typeface="Cambria Math" panose="02040503050406030204" pitchFamily="18" charset="0"/>
-                          </a:rPr>
-                          <m:t>𝑖</m:t>
-                        </m:r>
-                      </m:sub>
-                      <m:sup/>
-                      <m:e>
-                        <m:sSup>
-                          <m:sSupPr>
-                            <m:ctrlPr>
-                              <a:rPr lang="en-US" sz="1000" b="0" i="0" baseline="0" dirty="0">
-                                <a:latin typeface="Cambria Math" panose="02040503050406030204" pitchFamily="18" charset="0"/>
-                              </a:rPr>
-                            </m:ctrlPr>
-                          </m:sSupPr>
-                          <m:e>
-                            <m:d>
-                              <m:dPr>
-                                <m:ctrlPr>
-                                  <a:rPr lang="en-US" sz="1000" b="0" i="0" baseline="0" dirty="0">
-                                    <a:latin typeface="Cambria Math" panose="02040503050406030204" pitchFamily="18" charset="0"/>
-                                  </a:rPr>
-                                </m:ctrlPr>
-                              </m:dPr>
-                              <m:e>
-                                <m:sSub>
-                                  <m:sSubPr>
-                                    <m:ctrlPr>
-                                      <a:rPr lang="en-US" sz="1000" b="0" i="0" baseline="0" dirty="0">
-                                        <a:latin typeface="Cambria Math" panose="02040503050406030204" pitchFamily="18" charset="0"/>
-                                      </a:rPr>
-                                    </m:ctrlPr>
-                                  </m:sSubPr>
-                                  <m:e>
-                                    <m:acc>
-                                      <m:accPr>
-                                        <m:chr m:val="ˆ"/>
-                                        <m:ctrlPr>
-                                          <a:rPr lang="en-US" sz="1000" b="0" i="0" baseline="0" dirty="0">
-                                            <a:latin typeface="Cambria Math" panose="02040503050406030204" pitchFamily="18" charset="0"/>
-                                          </a:rPr>
-                                        </m:ctrlPr>
-                                      </m:accPr>
-                                      <m:e>
-                                        <m:r>
-                                          <a:rPr lang="en-US" sz="1000" b="0" i="0" baseline="0" dirty="0">
-                                            <a:latin typeface="Cambria Math" panose="02040503050406030204" pitchFamily="18" charset="0"/>
-                                          </a:rPr>
-                                          <m:t>𝐴</m:t>
-                                        </m:r>
-                                      </m:e>
-                                    </m:acc>
-                                  </m:e>
-                                  <m:sub>
-                                    <m:r>
-                                      <a:rPr lang="en-US" sz="1000" b="0" i="0" baseline="0" dirty="0">
-                                        <a:latin typeface="Cambria Math" panose="02040503050406030204" pitchFamily="18" charset="0"/>
-                                      </a:rPr>
-                                      <m:t>𝑖</m:t>
-                                    </m:r>
-                                  </m:sub>
-                                </m:sSub>
-                                <m:r>
-                                  <a:rPr lang="en-US" sz="1000" b="0" i="0" baseline="0" dirty="0">
-                                    <a:latin typeface="Cambria Math" panose="02040503050406030204" pitchFamily="18" charset="0"/>
-                                  </a:rPr>
-                                  <m:t>−</m:t>
-                                </m:r>
-                                <m:sSub>
-                                  <m:sSubPr>
-                                    <m:ctrlPr>
-                                      <a:rPr lang="en-US" sz="1000" b="0" i="0" baseline="0" dirty="0">
-                                        <a:latin typeface="Cambria Math" panose="02040503050406030204" pitchFamily="18" charset="0"/>
-                                      </a:rPr>
-                                    </m:ctrlPr>
-                                  </m:sSubPr>
-                                  <m:e>
-                                    <m:acc>
-                                      <m:accPr>
-                                        <m:chr m:val="ˆ"/>
-                                        <m:ctrlPr>
-                                          <a:rPr lang="en-US" sz="1000" b="0" i="0" baseline="0" dirty="0">
-                                            <a:latin typeface="Cambria Math" panose="02040503050406030204" pitchFamily="18" charset="0"/>
-                                          </a:rPr>
-                                        </m:ctrlPr>
-                                      </m:accPr>
-                                      <m:e>
-                                        <m:r>
-                                          <a:rPr lang="en-US" sz="1000" b="0" i="0" baseline="0" dirty="0">
-                                            <a:latin typeface="Cambria Math" panose="02040503050406030204" pitchFamily="18" charset="0"/>
-                                          </a:rPr>
-                                          <m:t>𝜇</m:t>
-                                        </m:r>
-                                      </m:e>
-                                    </m:acc>
-                                  </m:e>
-                                  <m:sub>
-                                    <m:r>
-                                      <a:rPr lang="en-US" sz="1000" b="0" i="0" baseline="0" dirty="0">
-                                        <a:latin typeface="Cambria Math" panose="02040503050406030204" pitchFamily="18" charset="0"/>
-                                      </a:rPr>
-                                      <m:t>𝑔</m:t>
-                                    </m:r>
-                                    <m:d>
-                                      <m:dPr>
-                                        <m:ctrlPr>
-                                          <a:rPr lang="en-US" sz="1000" b="0" i="0" baseline="0" dirty="0">
-                                            <a:latin typeface="Cambria Math" panose="02040503050406030204" pitchFamily="18" charset="0"/>
-                                          </a:rPr>
-                                        </m:ctrlPr>
-                                      </m:dPr>
-                                      <m:e>
-                                        <m:r>
-                                          <a:rPr lang="en-US" sz="1000" b="0" i="0" baseline="0" dirty="0">
-                                            <a:latin typeface="Cambria Math" panose="02040503050406030204" pitchFamily="18" charset="0"/>
-                                          </a:rPr>
-                                          <m:t>𝑖</m:t>
-                                        </m:r>
-                                      </m:e>
-                                    </m:d>
-                                  </m:sub>
-                                </m:sSub>
-                              </m:e>
-                            </m:d>
-                          </m:e>
-                          <m:sup>
-                            <m:r>
-                              <a:rPr lang="en-US" sz="1000" b="0" i="0" baseline="0" dirty="0">
-                                <a:latin typeface="Cambria Math" panose="02040503050406030204" pitchFamily="18" charset="0"/>
-                              </a:rPr>
-                              <m:t>2</m:t>
-                            </m:r>
-                          </m:sup>
-                        </m:sSup>
-                      </m:e>
-                    </m:nary>
-                    <m:r>
-                      <a:rPr lang="en-US" sz="1000" b="0" i="0" baseline="0" dirty="0">
-                        <a:latin typeface="Cambria Math" panose="02040503050406030204" pitchFamily="18" charset="0"/>
-                      </a:rPr>
-                      <m:t>/</m:t>
-                    </m:r>
-                    <m:nary>
-                      <m:naryPr>
-                        <m:chr m:val="∑"/>
-                        <m:limLoc m:val="undOvr"/>
-                        <m:supHide m:val="on"/>
-                        <m:ctrlPr>
-                          <a:rPr lang="en-US" sz="1000" b="0" i="0" baseline="0" dirty="0">
-                            <a:latin typeface="Cambria Math" panose="02040503050406030204" pitchFamily="18" charset="0"/>
-                          </a:rPr>
-                        </m:ctrlPr>
-                      </m:naryPr>
-                      <m:sub>
-                        <m:r>
-                          <a:rPr lang="en-US" sz="1000" b="0" i="0" baseline="0" dirty="0">
-                            <a:latin typeface="Cambria Math" panose="02040503050406030204" pitchFamily="18" charset="0"/>
-                          </a:rPr>
-                          <m:t>𝑖</m:t>
-                        </m:r>
-                      </m:sub>
-                      <m:sup/>
-                      <m:e>
-                        <m:sSup>
-                          <m:sSupPr>
-                            <m:ctrlPr>
-                              <a:rPr lang="en-US" sz="1000" b="0" i="0" baseline="0" dirty="0">
-                                <a:latin typeface="Cambria Math" panose="02040503050406030204" pitchFamily="18" charset="0"/>
-                              </a:rPr>
-                            </m:ctrlPr>
-                          </m:sSupPr>
-                          <m:e>
-                            <m:d>
-                              <m:dPr>
-                                <m:ctrlPr>
-                                  <a:rPr lang="en-US" sz="1000" b="0" i="0" baseline="0" dirty="0">
-                                    <a:latin typeface="Cambria Math" panose="02040503050406030204" pitchFamily="18" charset="0"/>
-                                  </a:rPr>
-                                </m:ctrlPr>
-                              </m:dPr>
-                              <m:e>
-                                <m:sSub>
-                                  <m:sSubPr>
-                                    <m:ctrlPr>
-                                      <a:rPr lang="en-US" sz="1000" b="0" i="0" baseline="0" dirty="0">
-                                        <a:latin typeface="Cambria Math" panose="02040503050406030204" pitchFamily="18" charset="0"/>
-                                      </a:rPr>
-                                    </m:ctrlPr>
-                                  </m:sSubPr>
-                                  <m:e>
-                                    <m:acc>
-                                      <m:accPr>
-                                        <m:chr m:val="ˆ"/>
-                                        <m:ctrlPr>
-                                          <a:rPr lang="en-US" sz="1000" b="0" i="0" baseline="0" dirty="0">
-                                            <a:latin typeface="Cambria Math" panose="02040503050406030204" pitchFamily="18" charset="0"/>
-                                          </a:rPr>
-                                        </m:ctrlPr>
-                                      </m:accPr>
-                                      <m:e>
-                                        <m:r>
-                                          <a:rPr lang="en-US" sz="1000" b="0" i="0" baseline="0" dirty="0">
-                                            <a:latin typeface="Cambria Math" panose="02040503050406030204" pitchFamily="18" charset="0"/>
-                                          </a:rPr>
-                                          <m:t>𝐴</m:t>
-                                        </m:r>
-                                      </m:e>
-                                    </m:acc>
-                                  </m:e>
-                                  <m:sub>
-                                    <m:r>
-                                      <a:rPr lang="en-US" sz="1000" b="0" i="0" baseline="0" dirty="0">
-                                        <a:latin typeface="Cambria Math" panose="02040503050406030204" pitchFamily="18" charset="0"/>
-                                      </a:rPr>
-                                      <m:t>𝑖</m:t>
-                                    </m:r>
-                                  </m:sub>
-                                </m:sSub>
-                                <m:r>
-                                  <a:rPr lang="en-US" sz="1000" b="0" i="0" baseline="0" dirty="0">
-                                    <a:latin typeface="Cambria Math" panose="02040503050406030204" pitchFamily="18" charset="0"/>
-                                  </a:rPr>
-                                  <m:t>−</m:t>
-                                </m:r>
-                                <m:acc>
-                                  <m:accPr>
-                                    <m:chr m:val="̅"/>
-                                    <m:ctrlPr>
-                                      <a:rPr lang="en-US" sz="1000" b="0" i="0" baseline="0" dirty="0">
-                                        <a:latin typeface="Cambria Math" panose="02040503050406030204" pitchFamily="18" charset="0"/>
-                                      </a:rPr>
-                                    </m:ctrlPr>
-                                  </m:accPr>
-                                  <m:e>
-                                    <m:r>
-                                      <a:rPr lang="en-US" sz="1000" b="0" i="0" baseline="0" dirty="0">
-                                        <a:latin typeface="Cambria Math" panose="02040503050406030204" pitchFamily="18" charset="0"/>
-                                      </a:rPr>
-                                      <m:t>𝐴</m:t>
-                                    </m:r>
-                                  </m:e>
-                                </m:acc>
-                              </m:e>
-                            </m:d>
-                          </m:e>
-                          <m:sup>
-                            <m:r>
-                              <a:rPr lang="en-US" sz="1000" b="0" i="0" baseline="0" dirty="0">
-                                <a:latin typeface="Cambria Math" panose="02040503050406030204" pitchFamily="18" charset="0"/>
-                              </a:rPr>
-                              <m:t>2</m:t>
-                            </m:r>
-                          </m:sup>
-                        </m:sSup>
-                      </m:e>
-                    </m:nary>
-                  </m:oMath>
-                </a14:m>
-                <a:r>
-                  <a:rPr sz="1000" b="0" i="0" baseline="0" dirty="0">
-                    <a:latin typeface="Calibri"/>
-                  </a:rPr>
-                  <a:t> — realized sorting on a fixed partition.</a:t>
-                </a:r>
-              </a:p>
-              <a:p>
-                <a:pPr>
-                  <a:lnSpc>
-                    <a:spcPct val="150000"/>
-                  </a:lnSpc>
-                  <a:buChar char="•"/>
-                </a:pPr>
-                <a:r>
-                  <a:rPr sz="1000" b="0" i="0" baseline="0" dirty="0">
-                    <a:latin typeface="Calibri"/>
-                  </a:rPr>
-                  <a:t>  NCAA partition: </a:t>
-                </a:r>
-                <a14:m>
-                  <m:oMath xmlns:m="http://schemas.openxmlformats.org/officeDocument/2006/math">
-                    <m:sSub>
-                      <m:sSubPr>
-                        <m:ctrlPr>
-                          <a:rPr lang="en-US" sz="1000" b="0" i="0" baseline="0" dirty="0">
-                            <a:latin typeface="Cambria Math" panose="02040503050406030204" pitchFamily="18" charset="0"/>
-                          </a:rPr>
-                        </m:ctrlPr>
-                      </m:sSubPr>
-                      <m:e>
-                        <m:r>
-                          <a:rPr lang="en-US" sz="1000" b="0" i="0" baseline="0" dirty="0">
-                            <a:latin typeface="Cambria Math" panose="02040503050406030204" pitchFamily="18" charset="0"/>
-                          </a:rPr>
-                          <m:t>𝐻</m:t>
-                        </m:r>
-                      </m:e>
-                      <m:sub>
-                        <m:r>
-                          <a:rPr lang="en-US" sz="1000" b="0" i="0" baseline="0" dirty="0">
-                            <a:latin typeface="Cambria Math" panose="02040503050406030204" pitchFamily="18" charset="0"/>
-                          </a:rPr>
-                          <m:t>𝑠𝑜𝑟𝑡</m:t>
-                        </m:r>
-                      </m:sub>
-                    </m:sSub>
-                    <m:r>
-                      <a:rPr lang="en-US" sz="1000" b="0" i="0" baseline="0" dirty="0">
-                        <a:latin typeface="Cambria Math" panose="02040503050406030204" pitchFamily="18" charset="0"/>
-                      </a:rPr>
-                      <m:t>=0.105</m:t>
-                    </m:r>
-                  </m:oMath>
-                </a14:m>
-                <a:r>
-                  <a:rPr sz="1000" b="0" i="0" baseline="0" dirty="0">
-                    <a:latin typeface="Calibri"/>
-                  </a:rPr>
-                  <a:t> (0 = none, 1 = full team sorting).</a:t>
-                </a:r>
-              </a:p>
-              <a:p>
-                <a:pPr>
-                  <a:lnSpc>
-                    <a:spcPct val="150000"/>
-                  </a:lnSpc>
-                  <a:buChar char="•"/>
-                </a:pPr>
-                <a:r>
-                  <a:rPr sz="1000" b="0" i="0" baseline="0" dirty="0">
-                    <a:latin typeface="Calibri"/>
-                  </a:rPr>
-                  <a:t>  Max coverage=3,117; sort-and-chop max=7. Normalized peak=0.97.</a:t>
-                </a:r>
-              </a:p>
-              <a:p>
-                <a:pPr>
-                  <a:lnSpc>
-                    <a:spcPct val="150000"/>
-                  </a:lnSpc>
-                  <a:buChar char="•"/>
-                </a:pPr>
-                <a:r>
-                  <a:rPr sz="1000" b="0" i="0" baseline="0" dirty="0">
-                    <a:latin typeface="Calibri"/>
-                  </a:rPr>
-                  <a:t>  </a:t>
-                </a:r>
-                <a14:m>
-                  <m:oMath xmlns:m="http://schemas.openxmlformats.org/officeDocument/2006/math">
-                    <m:r>
-                      <a:rPr lang="en-US" sz="1000" b="0" i="0" baseline="0" dirty="0" smtClean="0">
-                        <a:latin typeface="Cambria Math" panose="02040503050406030204" pitchFamily="18" charset="0"/>
-                      </a:rPr>
-                      <m:t>86%</m:t>
-                    </m:r>
-                  </m:oMath>
-                </a14:m>
-                <a:r>
-                  <a:rPr sz="1000" b="0" i="0" baseline="0" dirty="0">
-                    <a:latin typeface="Calibri"/>
-                  </a:rPr>
-                  <a:t> of grid points have </a:t>
-                </a:r>
-                <a14:m>
-                  <m:oMath xmlns:m="http://schemas.openxmlformats.org/officeDocument/2006/math">
-                    <m:r>
-                      <a:rPr lang="en-US" sz="1000" b="0" i="0" baseline="0" dirty="0" smtClean="0">
-                        <a:latin typeface="Cambria Math" panose="02040503050406030204" pitchFamily="18" charset="0"/>
-                      </a:rPr>
-                      <m:t>&gt;1</m:t>
-                    </m:r>
-                  </m:oMath>
-                </a14:m>
-                <a:r>
-                  <a:rPr sz="1000" b="0" i="0" baseline="0" dirty="0">
-                    <a:latin typeface="Calibri"/>
-                  </a:rPr>
-                  <a:t> team covering.</a:t>
-                </a:r>
-              </a:p>
-              <a:p>
-                <a:pPr>
-                  <a:lnSpc>
-                    <a:spcPct val="150000"/>
-                  </a:lnSpc>
-                  <a:buChar char="•"/>
-                </a:pPr>
-                <a:r>
-                  <a:rPr sz="1000" b="0" i="0" baseline="0" dirty="0">
-                    <a:latin typeface="Calibri"/>
-                  </a:rPr>
-                  <a:t>  Roster span: mean=2.99 z, median=2.85 z (3,200 team-seasons).</a:t>
-                </a:r>
-              </a:p>
-              <a:p>
-                <a:pPr>
-                  <a:lnSpc>
-                    <a:spcPct val="150000"/>
-                  </a:lnSpc>
-                  <a:buChar char="•"/>
-                </a:pPr>
-                <a:r>
-                  <a:rPr sz="1000" b="0" i="0" baseline="0" dirty="0">
-                    <a:latin typeface="Calibri"/>
-                  </a:rPr>
-                  <a:t>  Paired compare window — match season span to Grandchild sim slide.</a:t>
-                </a:r>
-              </a:p>
-              <a:p>
-                <a:pPr>
-                  <a:lnSpc>
-                    <a:spcPct val="150000"/>
-                  </a:lnSpc>
-                  <a:buChar char="•"/>
-                </a:pPr>
-                <a:r>
-                  <a:rPr sz="1000" b="0" i="0" baseline="0" dirty="0">
-                    <a:latin typeface="Calibri"/>
-                  </a:rPr>
-                  <a:t>  VECTOR lock: </a:t>
-                </a:r>
-                <a14:m>
-                  <m:oMath xmlns:m="http://schemas.openxmlformats.org/officeDocument/2006/math">
-                    <m:sSub>
-                      <m:sSubPr>
-                        <m:ctrlPr>
-                          <a:rPr lang="en-US" sz="1000" b="0" i="0" baseline="0" dirty="0">
-                            <a:latin typeface="Cambria Math" panose="02040503050406030204" pitchFamily="18" charset="0"/>
-                          </a:rPr>
-                        </m:ctrlPr>
-                      </m:sSubPr>
-                      <m:e>
-                        <m:r>
-                          <a:rPr lang="en-US" sz="1000" b="0" i="0" baseline="0" dirty="0">
-                            <a:latin typeface="Cambria Math" panose="02040503050406030204" pitchFamily="18" charset="0"/>
-                          </a:rPr>
-                          <m:t>𝐻</m:t>
-                        </m:r>
-                      </m:e>
-                      <m:sub>
-                        <m:r>
-                          <a:rPr lang="en-US" sz="1000" b="0" i="0" baseline="0" dirty="0">
-                            <a:latin typeface="Cambria Math" panose="02040503050406030204" pitchFamily="18" charset="0"/>
-                          </a:rPr>
-                          <m:t>𝑠𝑜𝑟𝑡</m:t>
-                        </m:r>
-                      </m:sub>
-                    </m:sSub>
-                  </m:oMath>
-                </a14:m>
-                <a:r>
-                  <a:rPr sz="1000" b="0" i="0" baseline="0" dirty="0">
-                    <a:latin typeface="Calibri"/>
-                  </a:rPr>
-                  <a:t> is realized sorting — not the generative homophily knob </a:t>
-                </a:r>
-                <a14:m>
-                  <m:oMath xmlns:m="http://schemas.openxmlformats.org/officeDocument/2006/math">
-                    <m:r>
-                      <a:rPr lang="en-US" sz="1000" b="0" i="0" baseline="0" dirty="0" smtClean="0">
-                        <a:latin typeface="Cambria Math" panose="02040503050406030204" pitchFamily="18" charset="0"/>
-                      </a:rPr>
-                      <m:t>𝜌</m:t>
-                    </m:r>
-                  </m:oMath>
-                </a14:m>
-                <a:r>
-                  <a:rPr sz="1000" b="0" i="0" baseline="0" dirty="0">
-                    <a:latin typeface="Calibri"/>
-                  </a:rPr>
-                  <a:t>.</a:t>
-                </a:r>
-              </a:p>
-            </p:txBody>
-          </p:sp>
-        </mc:Choice>
-        <mc:Fallback>
-          <p:sp>
-            <p:nvSpPr>
-              <p:cNvPr id="5" name="TextBox 4"/>
-              <p:cNvSpPr txBox="1">
-                <a:spLocks noRot="1" noChangeAspect="1" noMove="1" noResize="1" noEditPoints="1" noAdjustHandles="1" noChangeArrowheads="1" noChangeShapeType="1" noTextEdit="1"/>
-              </p:cNvSpPr>
-              <p:nvPr/>
-            </p:nvSpPr>
-            <p:spPr>
-              <a:xfrm>
-                <a:off x="384047" y="1202289"/>
-                <a:ext cx="4387055" cy="2704074"/>
-              </a:xfrm>
-              <a:prstGeom prst="rect">
-                <a:avLst/>
-              </a:prstGeom>
-              <a:blipFill>
-                <a:blip r:embed="rId5"/>
-                <a:stretch>
-                  <a:fillRect b="-467"/>
-                </a:stretch>
-              </a:blipFill>
-            </p:spPr>
-            <p:txBody>
-              <a:bodyPr/>
-              <a:lstStyle/>
-              <a:p>
-                <a:r>
-                  <a:rPr lang="en-US">
-                    <a:noFill/>
-                  </a:rPr>
-                  <a:t> </a:t>
-                </a:r>
-              </a:p>
-            </p:txBody>
-          </p:sp>
-        </mc:Fallback>
-      </mc:AlternateContent>
+      <p:sp>
+        <p:nvSpPr>
+          <p:cNvPr id="5" name="TextBox 4"/>
+          <p:cNvSpPr txBox="1"/>
+          <p:nvPr/>
+        </p:nvSpPr>
+        <p:spPr>
+          <a:xfrm>
+            <a:off x="384048" y="3849624"/>
+            <a:ext cx="3794760" cy="2148840"/>
+          </a:xfrm>
+          <a:prstGeom prst="rect">
+            <a:avLst/>
+          </a:prstGeom>
+          <a:noFill/>
+        </p:spPr>
+        <p:txBody>
+          <a:bodyPr wrap="square">
+            <a:spAutoFit/>
+          </a:bodyPr>
+          <a:lstStyle/>
+          <a:p>
+            <a:pPr>
+              <a:buChar char="•"/>
+              <a:lnSpc>
+                <a:spcPct val="150000"/>
+              </a:lnSpc>
+              <a:spcBef>
+                <a:spcPts val="0"/>
+              </a:spcBef>
+              <a:spcAft>
+                <a:spcPts val="0"/>
+              </a:spcAft>
+            </a:pPr>
+            <a:r>
+              <a:rPr sz="1000" b="0" i="0" baseline="0">
+                <a:latin typeface="Calibri"/>
+              </a:rPr>
+              <a:t>  Each team-season: talent window [\min \hat{A}_{i}, \max \hat{A}_{i}] on PPM z.</a:t>
+            </a:r>
+          </a:p>
+          <a:p>
+            <a:pPr>
+              <a:buChar char="•"/>
+              <a:lnSpc>
+                <a:spcPct val="150000"/>
+              </a:lnSpc>
+              <a:spcBef>
+                <a:spcPts val="0"/>
+              </a:spcBef>
+              <a:spcAft>
+                <a:spcPts val="0"/>
+              </a:spcAft>
+            </a:pPr>
+            <a:r>
+              <a:rPr sz="1000" b="0" i="0" baseline="0">
+                <a:latin typeface="Calibri"/>
+              </a:rPr>
+              <a:t>  Coverage = how many windows cover a point on the spectrum (530 CELL 8).</a:t>
+            </a:r>
+          </a:p>
+          <a:p>
+            <a:pPr>
+              <a:buChar char="•"/>
+              <a:lnSpc>
+                <a:spcPct val="150000"/>
+              </a:lnSpc>
+              <a:spcBef>
+                <a:spcPts val="0"/>
+              </a:spcBef>
+              <a:spcAft>
+                <a:spcPts val="0"/>
+              </a:spcAft>
+            </a:pPr>
+            <a:r>
+              <a:rPr sz="1000" b="0" i="0" baseline="0">
+                <a:latin typeface="Calibri"/>
+              </a:rPr>
+              <a:t>  Red dashed: disjoint sort-and-chop on same player-seasons (537 B analog).</a:t>
+            </a:r>
+          </a:p>
+          <a:p>
+            <a:pPr>
+              <a:buChar char="•"/>
+              <a:lnSpc>
+                <a:spcPct val="150000"/>
+              </a:lnSpc>
+              <a:spcBef>
+                <a:spcPts val="0"/>
+              </a:spcBef>
+              <a:spcAft>
+                <a:spcPts val="0"/>
+              </a:spcAft>
+            </a:pPr>
+            <a:r>
+              <a:rPr sz="1000" b="0" i="0" baseline="0">
+                <a:latin typeface="Calibri"/>
+              </a:rPr>
+              <a:t>  H_{sort} = 1 - \sum_i(\hat{A}_i - \hat{\mu}_{g(i)})^2 / \sum_i(\hat{A}_i - \bar{A})^2 — realized sorting on a fixed partition.</a:t>
+            </a:r>
+          </a:p>
+          <a:p>
+            <a:pPr>
+              <a:buChar char="•"/>
+              <a:lnSpc>
+                <a:spcPct val="150000"/>
+              </a:lnSpc>
+              <a:spcBef>
+                <a:spcPts val="0"/>
+              </a:spcBef>
+              <a:spcAft>
+                <a:spcPts val="0"/>
+              </a:spcAft>
+            </a:pPr>
+            <a:r>
+              <a:rPr sz="1000" b="0" i="0" baseline="0">
+                <a:latin typeface="Calibri"/>
+              </a:rPr>
+              <a:t>  NCAA partition: H_{sort} = 0.105 (0 = none, 1 = full team sorting).</a:t>
+            </a:r>
+          </a:p>
+          <a:p>
+            <a:pPr>
+              <a:buChar char="•"/>
+              <a:lnSpc>
+                <a:spcPct val="150000"/>
+              </a:lnSpc>
+              <a:spcBef>
+                <a:spcPts val="0"/>
+              </a:spcBef>
+              <a:spcAft>
+                <a:spcPts val="0"/>
+              </a:spcAft>
+            </a:pPr>
+            <a:r>
+              <a:rPr sz="1000" b="0" i="0" baseline="0">
+                <a:latin typeface="Calibri"/>
+              </a:rPr>
+              <a:t>  Max coverage=3,117; sort-and-chop max=7. Normalized peak=0.97.</a:t>
+            </a:r>
+          </a:p>
+          <a:p>
+            <a:pPr>
+              <a:buChar char="•"/>
+              <a:lnSpc>
+                <a:spcPct val="150000"/>
+              </a:lnSpc>
+              <a:spcBef>
+                <a:spcPts val="0"/>
+              </a:spcBef>
+              <a:spcAft>
+                <a:spcPts val="0"/>
+              </a:spcAft>
+            </a:pPr>
+            <a:r>
+              <a:rPr sz="1000" b="0" i="0" baseline="0">
+                <a:latin typeface="Calibri"/>
+              </a:rPr>
+              <a:t>  86\% of grid points have &gt;1 team covering.</a:t>
+            </a:r>
+          </a:p>
+          <a:p>
+            <a:pPr>
+              <a:buChar char="•"/>
+              <a:lnSpc>
+                <a:spcPct val="150000"/>
+              </a:lnSpc>
+              <a:spcBef>
+                <a:spcPts val="0"/>
+              </a:spcBef>
+              <a:spcAft>
+                <a:spcPts val="0"/>
+              </a:spcAft>
+            </a:pPr>
+            <a:r>
+              <a:rPr sz="1000" b="0" i="0" baseline="0">
+                <a:latin typeface="Calibri"/>
+              </a:rPr>
+              <a:t>  Roster span: mean=2.99 z, median=2.85 z (3,200 team-seasons).</a:t>
+            </a:r>
+          </a:p>
+          <a:p>
+            <a:pPr>
+              <a:buChar char="•"/>
+              <a:lnSpc>
+                <a:spcPct val="150000"/>
+              </a:lnSpc>
+              <a:spcBef>
+                <a:spcPts val="0"/>
+              </a:spcBef>
+              <a:spcAft>
+                <a:spcPts val="0"/>
+              </a:spcAft>
+            </a:pPr>
+            <a:r>
+              <a:rPr sz="1000" b="0" i="0" baseline="0">
+                <a:latin typeface="Calibri"/>
+              </a:rPr>
+              <a:t>  Paired compare window — match season span to LG sim slide.</a:t>
+            </a:r>
+          </a:p>
+          <a:p>
+            <a:pPr>
+              <a:buChar char="•"/>
+              <a:lnSpc>
+                <a:spcPct val="150000"/>
+              </a:lnSpc>
+              <a:spcBef>
+                <a:spcPts val="0"/>
+              </a:spcBef>
+              <a:spcAft>
+                <a:spcPts val="0"/>
+              </a:spcAft>
+            </a:pPr>
+            <a:r>
+              <a:rPr sz="1000" b="0" i="0" baseline="0">
+                <a:latin typeface="Calibri"/>
+              </a:rPr>
+              <a:t>  VECTOR lock: H_{sort} is realized sorting — not the generative homophily knob \rho.</a:t>
+            </a:r>
+          </a:p>
+        </p:txBody>
+      </p:sp>
       <p:sp>
         <p:nvSpPr>
           <p:cNvPr id="6" name="TextBox 5"/>
@@ -4170,7 +3424,7 @@
               <a:rPr sz="1100" b="1" i="0" baseline="0">
                 <a:latin typeface="Calibri"/>
               </a:rPr>
-              <a:t>Claim: NCAA interval overlap on a fixed season window — paired compare to Grandchild ASSIGN sim on the same window.</a:t>
+              <a:t>Claim: NCAA interval overlap on a fixed season window — paired compare to LG ASSIGN sim on the same window.</a:t>
             </a:r>
           </a:p>
         </p:txBody>

</xml_diff>